<commit_message>
Updates slides for graphs 2 lecture to fix title page.
Signed-off-by: Charlie Murphy <tcm3@cs.princeton.edu>
</commit_message>
<xml_diff>
--- a/courses/csci246/spring26/slides/04_10_26_graphs2.pptx
+++ b/courses/csci246/spring26/slides/04_10_26_graphs2.pptx
@@ -230,7 +230,7 @@
           <a:p>
             <a:fld id="{B7930911-D214-D045-9349-C37725674895}" type="datetimeFigureOut">
               <a:rPr lang="en-US" smtClean="0"/>
-              <a:t>4/9/2026</a:t>
+              <a:t>4/10/26</a:t>
             </a:fld>
             <a:endParaRPr lang="en-US"/>
           </a:p>
@@ -1784,7 +1784,7 @@
           <a:p>
             <a:fld id="{05900130-2E42-9F4E-B9EA-739EF1E7DBD9}" type="datetimeFigureOut">
               <a:rPr lang="en-US" smtClean="0"/>
-              <a:t>4/9/2026</a:t>
+              <a:t>4/10/26</a:t>
             </a:fld>
             <a:endParaRPr lang="en-US"/>
           </a:p>
@@ -1982,7 +1982,7 @@
           <a:p>
             <a:fld id="{05900130-2E42-9F4E-B9EA-739EF1E7DBD9}" type="datetimeFigureOut">
               <a:rPr lang="en-US" smtClean="0"/>
-              <a:t>4/9/2026</a:t>
+              <a:t>4/10/26</a:t>
             </a:fld>
             <a:endParaRPr lang="en-US"/>
           </a:p>
@@ -2190,7 +2190,7 @@
           <a:p>
             <a:fld id="{05900130-2E42-9F4E-B9EA-739EF1E7DBD9}" type="datetimeFigureOut">
               <a:rPr lang="en-US" smtClean="0"/>
-              <a:t>4/9/2026</a:t>
+              <a:t>4/10/26</a:t>
             </a:fld>
             <a:endParaRPr lang="en-US"/>
           </a:p>
@@ -2388,7 +2388,7 @@
           <a:p>
             <a:fld id="{05900130-2E42-9F4E-B9EA-739EF1E7DBD9}" type="datetimeFigureOut">
               <a:rPr lang="en-US" smtClean="0"/>
-              <a:t>4/9/2026</a:t>
+              <a:t>4/10/26</a:t>
             </a:fld>
             <a:endParaRPr lang="en-US"/>
           </a:p>
@@ -2663,7 +2663,7 @@
           <a:p>
             <a:fld id="{05900130-2E42-9F4E-B9EA-739EF1E7DBD9}" type="datetimeFigureOut">
               <a:rPr lang="en-US" smtClean="0"/>
-              <a:t>4/9/2026</a:t>
+              <a:t>4/10/26</a:t>
             </a:fld>
             <a:endParaRPr lang="en-US"/>
           </a:p>
@@ -2928,7 +2928,7 @@
           <a:p>
             <a:fld id="{05900130-2E42-9F4E-B9EA-739EF1E7DBD9}" type="datetimeFigureOut">
               <a:rPr lang="en-US" smtClean="0"/>
-              <a:t>4/9/2026</a:t>
+              <a:t>4/10/26</a:t>
             </a:fld>
             <a:endParaRPr lang="en-US"/>
           </a:p>
@@ -3340,7 +3340,7 @@
           <a:p>
             <a:fld id="{05900130-2E42-9F4E-B9EA-739EF1E7DBD9}" type="datetimeFigureOut">
               <a:rPr lang="en-US" smtClean="0"/>
-              <a:t>4/9/2026</a:t>
+              <a:t>4/10/26</a:t>
             </a:fld>
             <a:endParaRPr lang="en-US"/>
           </a:p>
@@ -3481,7 +3481,7 @@
           <a:p>
             <a:fld id="{05900130-2E42-9F4E-B9EA-739EF1E7DBD9}" type="datetimeFigureOut">
               <a:rPr lang="en-US" smtClean="0"/>
-              <a:t>4/9/2026</a:t>
+              <a:t>4/10/26</a:t>
             </a:fld>
             <a:endParaRPr lang="en-US"/>
           </a:p>
@@ -3594,7 +3594,7 @@
           <a:p>
             <a:fld id="{05900130-2E42-9F4E-B9EA-739EF1E7DBD9}" type="datetimeFigureOut">
               <a:rPr lang="en-US" smtClean="0"/>
-              <a:t>4/9/2026</a:t>
+              <a:t>4/10/26</a:t>
             </a:fld>
             <a:endParaRPr lang="en-US"/>
           </a:p>
@@ -3905,7 +3905,7 @@
           <a:p>
             <a:fld id="{05900130-2E42-9F4E-B9EA-739EF1E7DBD9}" type="datetimeFigureOut">
               <a:rPr lang="en-US" smtClean="0"/>
-              <a:t>4/9/2026</a:t>
+              <a:t>4/10/26</a:t>
             </a:fld>
             <a:endParaRPr lang="en-US"/>
           </a:p>
@@ -4193,7 +4193,7 @@
           <a:p>
             <a:fld id="{05900130-2E42-9F4E-B9EA-739EF1E7DBD9}" type="datetimeFigureOut">
               <a:rPr lang="en-US" smtClean="0"/>
-              <a:t>4/9/2026</a:t>
+              <a:t>4/10/26</a:t>
             </a:fld>
             <a:endParaRPr lang="en-US"/>
           </a:p>
@@ -4434,7 +4434,7 @@
           <a:p>
             <a:fld id="{05900130-2E42-9F4E-B9EA-739EF1E7DBD9}" type="datetimeFigureOut">
               <a:rPr lang="en-US" smtClean="0"/>
-              <a:t>4/9/2026</a:t>
+              <a:t>4/10/26</a:t>
             </a:fld>
             <a:endParaRPr lang="en-US"/>
           </a:p>
@@ -4885,7 +4885,7 @@
                 <a:latin typeface="Arial" panose="020B0604020202020204" pitchFamily="34" charset="0"/>
                 <a:cs typeface="Arial" panose="020B0604020202020204" pitchFamily="34" charset="0"/>
               </a:rPr>
-              <a:t>Graphs I</a:t>
+              <a:t>Graphs II</a:t>
             </a:r>
             <a:br>
               <a:rPr lang="en-US" dirty="0">
@@ -4898,7 +4898,7 @@
                 <a:latin typeface="Arial" panose="020B0604020202020204" pitchFamily="34" charset="0"/>
                 <a:cs typeface="Arial" panose="020B0604020202020204" pitchFamily="34" charset="0"/>
               </a:rPr>
-              <a:t>April 8, 2026</a:t>
+              <a:t>April 10, 2026</a:t>
             </a:r>
             <a:endParaRPr lang="en-US" sz="7200" dirty="0">
               <a:latin typeface="Arial" panose="020B0604020202020204" pitchFamily="34" charset="0"/>
@@ -4949,7 +4949,7 @@
                 <a:latin typeface="Arial" panose="020B0604020202020204" pitchFamily="34" charset="0"/>
                 <a:cs typeface="Arial" panose="020B0604020202020204" pitchFamily="34" charset="0"/>
               </a:rPr>
-              <a:t>Textbook Reference: Ch. 9, Sec. 47</a:t>
+              <a:t>Textbook Reference: Ch. 9, Sec. 48</a:t>
             </a:r>
           </a:p>
         </p:txBody>
@@ -5065,8 +5065,8 @@
           </a:p>
         </p:txBody>
       </p:sp>
-      <mc:AlternateContent xmlns:mc="http://schemas.openxmlformats.org/markup-compatibility/2006">
-        <mc:Choice xmlns:a14="http://schemas.microsoft.com/office/drawing/2010/main" Requires="a14">
+      <mc:AlternateContent xmlns:mc="http://schemas.openxmlformats.org/markup-compatibility/2006" xmlns:a14="http://schemas.microsoft.com/office/drawing/2010/main">
+        <mc:Choice Requires="a14">
           <p:sp>
             <p:nvSpPr>
               <p:cNvPr id="3" name="Content Placeholder 14">
@@ -5344,7 +5344,7 @@
             </p:txBody>
           </p:sp>
         </mc:Choice>
-        <mc:Fallback>
+        <mc:Fallback xmlns="">
           <p:sp>
             <p:nvSpPr>
               <p:cNvPr id="3" name="Content Placeholder 14">
@@ -6570,8 +6570,8 @@
           </a:p>
         </p:txBody>
       </p:sp>
-      <mc:AlternateContent xmlns:mc="http://schemas.openxmlformats.org/markup-compatibility/2006">
-        <mc:Choice xmlns:a14="http://schemas.microsoft.com/office/drawing/2010/main" Requires="a14">
+      <mc:AlternateContent xmlns:mc="http://schemas.openxmlformats.org/markup-compatibility/2006" xmlns:a14="http://schemas.microsoft.com/office/drawing/2010/main">
+        <mc:Choice Requires="a14">
           <p:sp>
             <p:nvSpPr>
               <p:cNvPr id="3" name="Content Placeholder 14">
@@ -6874,7 +6874,7 @@
             </p:txBody>
           </p:sp>
         </mc:Choice>
-        <mc:Fallback>
+        <mc:Fallback xmlns="">
           <p:sp>
             <p:nvSpPr>
               <p:cNvPr id="3" name="Content Placeholder 14">
@@ -7730,8 +7730,8 @@
           </a:p>
         </p:txBody>
       </p:sp>
-      <mc:AlternateContent xmlns:mc="http://schemas.openxmlformats.org/markup-compatibility/2006">
-        <mc:Choice xmlns:a14="http://schemas.microsoft.com/office/drawing/2010/main" Requires="a14">
+      <mc:AlternateContent xmlns:mc="http://schemas.openxmlformats.org/markup-compatibility/2006" xmlns:a14="http://schemas.microsoft.com/office/drawing/2010/main">
+        <mc:Choice Requires="a14">
           <p:sp>
             <p:nvSpPr>
               <p:cNvPr id="55" name="TextBox 54">
@@ -7793,7 +7793,7 @@
             </p:txBody>
           </p:sp>
         </mc:Choice>
-        <mc:Fallback>
+        <mc:Fallback xmlns="">
           <p:sp>
             <p:nvSpPr>
               <p:cNvPr id="55" name="TextBox 54">
@@ -7838,8 +7838,8 @@
           </p:sp>
         </mc:Fallback>
       </mc:AlternateContent>
-      <mc:AlternateContent xmlns:mc="http://schemas.openxmlformats.org/markup-compatibility/2006">
-        <mc:Choice xmlns:a14="http://schemas.microsoft.com/office/drawing/2010/main" Requires="a14">
+      <mc:AlternateContent xmlns:mc="http://schemas.openxmlformats.org/markup-compatibility/2006" xmlns:a14="http://schemas.microsoft.com/office/drawing/2010/main">
+        <mc:Choice Requires="a14">
           <p:sp>
             <p:nvSpPr>
               <p:cNvPr id="56" name="TextBox 55">
@@ -7889,7 +7889,7 @@
             </p:txBody>
           </p:sp>
         </mc:Choice>
-        <mc:Fallback>
+        <mc:Fallback xmlns="">
           <p:sp>
             <p:nvSpPr>
               <p:cNvPr id="56" name="TextBox 55">
@@ -9546,8 +9546,8 @@
           </a:p>
         </p:txBody>
       </p:sp>
-      <mc:AlternateContent xmlns:mc="http://schemas.openxmlformats.org/markup-compatibility/2006">
-        <mc:Choice xmlns:a14="http://schemas.microsoft.com/office/drawing/2010/main" Requires="a14">
+      <mc:AlternateContent xmlns:mc="http://schemas.openxmlformats.org/markup-compatibility/2006" xmlns:a14="http://schemas.microsoft.com/office/drawing/2010/main">
+        <mc:Choice Requires="a14">
           <p:sp>
             <p:nvSpPr>
               <p:cNvPr id="3" name="Content Placeholder 14">
@@ -9700,7 +9700,7 @@
             </p:txBody>
           </p:sp>
         </mc:Choice>
-        <mc:Fallback>
+        <mc:Fallback xmlns="">
           <p:sp>
             <p:nvSpPr>
               <p:cNvPr id="3" name="Content Placeholder 14">
@@ -10556,8 +10556,8 @@
           </a:p>
         </p:txBody>
       </p:sp>
-      <mc:AlternateContent xmlns:mc="http://schemas.openxmlformats.org/markup-compatibility/2006">
-        <mc:Choice xmlns:a14="http://schemas.microsoft.com/office/drawing/2010/main" Requires="a14">
+      <mc:AlternateContent xmlns:mc="http://schemas.openxmlformats.org/markup-compatibility/2006" xmlns:a14="http://schemas.microsoft.com/office/drawing/2010/main">
+        <mc:Choice Requires="a14">
           <p:sp>
             <p:nvSpPr>
               <p:cNvPr id="55" name="TextBox 54">
@@ -10619,7 +10619,7 @@
             </p:txBody>
           </p:sp>
         </mc:Choice>
-        <mc:Fallback>
+        <mc:Fallback xmlns="">
           <p:sp>
             <p:nvSpPr>
               <p:cNvPr id="55" name="TextBox 54">
@@ -10664,8 +10664,8 @@
           </p:sp>
         </mc:Fallback>
       </mc:AlternateContent>
-      <mc:AlternateContent xmlns:mc="http://schemas.openxmlformats.org/markup-compatibility/2006">
-        <mc:Choice xmlns:a14="http://schemas.microsoft.com/office/drawing/2010/main" Requires="a14">
+      <mc:AlternateContent xmlns:mc="http://schemas.openxmlformats.org/markup-compatibility/2006" xmlns:a14="http://schemas.microsoft.com/office/drawing/2010/main">
+        <mc:Choice Requires="a14">
           <p:sp>
             <p:nvSpPr>
               <p:cNvPr id="56" name="TextBox 55">
@@ -10715,7 +10715,7 @@
             </p:txBody>
           </p:sp>
         </mc:Choice>
-        <mc:Fallback>
+        <mc:Fallback xmlns="">
           <p:sp>
             <p:nvSpPr>
               <p:cNvPr id="56" name="TextBox 55">
@@ -12873,7 +12873,7 @@
                 <a:latin typeface="Arial" panose="020B0604020202020204" pitchFamily="34" charset="0"/>
                 <a:cs typeface="Arial" panose="020B0604020202020204" pitchFamily="34" charset="0"/>
               </a:rPr>
-              <a:t>Released by Tomorrow.</a:t>
+              <a:t>Released today.</a:t>
             </a:r>
           </a:p>
           <a:p>
@@ -14672,8 +14672,8 @@
           </a:p>
         </p:txBody>
       </p:sp>
-      <mc:AlternateContent xmlns:mc="http://schemas.openxmlformats.org/markup-compatibility/2006">
-        <mc:Choice xmlns:a14="http://schemas.microsoft.com/office/drawing/2010/main" Requires="a14">
+      <mc:AlternateContent xmlns:mc="http://schemas.openxmlformats.org/markup-compatibility/2006" xmlns:a14="http://schemas.microsoft.com/office/drawing/2010/main">
+        <mc:Choice Requires="a14">
           <p:sp>
             <p:nvSpPr>
               <p:cNvPr id="3" name="Content Placeholder 14">
@@ -14819,14 +14819,7 @@
                             <a:latin typeface="Cambria Math" panose="02040503050406030204" pitchFamily="18" charset="0"/>
                             <a:cs typeface="Arial" panose="020B0604020202020204" pitchFamily="34" charset="0"/>
                           </a:rPr>
-                          <m:t>′</m:t>
-                        </m:r>
-                        <m:r>
-                          <a:rPr lang="en-US" b="0" i="1" smtClean="0">
-                            <a:latin typeface="Cambria Math" panose="02040503050406030204" pitchFamily="18" charset="0"/>
-                            <a:cs typeface="Arial" panose="020B0604020202020204" pitchFamily="34" charset="0"/>
-                          </a:rPr>
-                          <m:t>, </m:t>
+                          <m:t>′, </m:t>
                         </m:r>
                         <m:r>
                           <a:rPr lang="en-US" b="0" i="1" smtClean="0">
@@ -15027,7 +15020,7 @@
             </p:txBody>
           </p:sp>
         </mc:Choice>
-        <mc:Fallback>
+        <mc:Fallback xmlns="">
           <p:sp>
             <p:nvSpPr>
               <p:cNvPr id="3" name="Content Placeholder 14">
@@ -16023,8 +16016,8 @@
           </a:fontRef>
         </p:style>
       </p:cxnSp>
-      <mc:AlternateContent xmlns:mc="http://schemas.openxmlformats.org/markup-compatibility/2006">
-        <mc:Choice xmlns:a14="http://schemas.microsoft.com/office/drawing/2010/main" Requires="a14">
+      <mc:AlternateContent xmlns:mc="http://schemas.openxmlformats.org/markup-compatibility/2006" xmlns:a14="http://schemas.microsoft.com/office/drawing/2010/main">
+        <mc:Choice Requires="a14">
           <p:sp>
             <p:nvSpPr>
               <p:cNvPr id="35" name="TextBox 34">
@@ -16053,6 +16046,7 @@
               </a:bodyPr>
               <a:lstStyle/>
               <a:p>
+                <a:pPr/>
                 <a14:m>
                   <m:oMathPara xmlns:m="http://schemas.openxmlformats.org/officeDocument/2006/math">
                     <m:oMathParaPr>
@@ -16073,7 +16067,7 @@
             </p:txBody>
           </p:sp>
         </mc:Choice>
-        <mc:Fallback>
+        <mc:Fallback xmlns="">
           <p:sp>
             <p:nvSpPr>
               <p:cNvPr id="35" name="TextBox 34">
@@ -16118,8 +16112,8 @@
           </p:sp>
         </mc:Fallback>
       </mc:AlternateContent>
-      <mc:AlternateContent xmlns:mc="http://schemas.openxmlformats.org/markup-compatibility/2006">
-        <mc:Choice xmlns:a14="http://schemas.microsoft.com/office/drawing/2010/main" Requires="a14">
+      <mc:AlternateContent xmlns:mc="http://schemas.openxmlformats.org/markup-compatibility/2006" xmlns:a14="http://schemas.microsoft.com/office/drawing/2010/main">
+        <mc:Choice Requires="a14">
           <p:sp>
             <p:nvSpPr>
               <p:cNvPr id="36" name="TextBox 35">
@@ -16148,6 +16142,7 @@
               </a:bodyPr>
               <a:lstStyle/>
               <a:p>
+                <a:pPr/>
                 <a14:m>
                   <m:oMathPara xmlns:m="http://schemas.openxmlformats.org/officeDocument/2006/math">
                     <m:oMathParaPr>
@@ -16168,7 +16163,7 @@
             </p:txBody>
           </p:sp>
         </mc:Choice>
-        <mc:Fallback>
+        <mc:Fallback xmlns="">
           <p:sp>
             <p:nvSpPr>
               <p:cNvPr id="36" name="TextBox 35">
@@ -16899,8 +16894,8 @@
           </a:p>
         </p:txBody>
       </p:sp>
-      <mc:AlternateContent xmlns:mc="http://schemas.openxmlformats.org/markup-compatibility/2006">
-        <mc:Choice xmlns:a14="http://schemas.microsoft.com/office/drawing/2010/main" Requires="a14">
+      <mc:AlternateContent xmlns:mc="http://schemas.openxmlformats.org/markup-compatibility/2006" xmlns:a14="http://schemas.microsoft.com/office/drawing/2010/main">
+        <mc:Choice Requires="a14">
           <p:sp>
             <p:nvSpPr>
               <p:cNvPr id="3" name="Content Placeholder 14">
@@ -17212,7 +17207,7 @@
             </p:txBody>
           </p:sp>
         </mc:Choice>
-        <mc:Fallback>
+        <mc:Fallback xmlns="">
           <p:sp>
             <p:nvSpPr>
               <p:cNvPr id="3" name="Content Placeholder 14">
@@ -18208,8 +18203,8 @@
           </a:fontRef>
         </p:style>
       </p:cxnSp>
-      <mc:AlternateContent xmlns:mc="http://schemas.openxmlformats.org/markup-compatibility/2006">
-        <mc:Choice xmlns:a14="http://schemas.microsoft.com/office/drawing/2010/main" Requires="a14">
+      <mc:AlternateContent xmlns:mc="http://schemas.openxmlformats.org/markup-compatibility/2006" xmlns:a14="http://schemas.microsoft.com/office/drawing/2010/main">
+        <mc:Choice Requires="a14">
           <p:sp>
             <p:nvSpPr>
               <p:cNvPr id="35" name="TextBox 34">
@@ -18259,7 +18254,7 @@
             </p:txBody>
           </p:sp>
         </mc:Choice>
-        <mc:Fallback>
+        <mc:Fallback xmlns="">
           <p:sp>
             <p:nvSpPr>
               <p:cNvPr id="35" name="TextBox 34">
@@ -18304,8 +18299,8 @@
           </p:sp>
         </mc:Fallback>
       </mc:AlternateContent>
-      <mc:AlternateContent xmlns:mc="http://schemas.openxmlformats.org/markup-compatibility/2006">
-        <mc:Choice xmlns:a14="http://schemas.microsoft.com/office/drawing/2010/main" Requires="a14">
+      <mc:AlternateContent xmlns:mc="http://schemas.openxmlformats.org/markup-compatibility/2006" xmlns:a14="http://schemas.microsoft.com/office/drawing/2010/main">
+        <mc:Choice Requires="a14">
           <p:sp>
             <p:nvSpPr>
               <p:cNvPr id="36" name="TextBox 35">
@@ -18355,7 +18350,7 @@
             </p:txBody>
           </p:sp>
         </mc:Choice>
-        <mc:Fallback>
+        <mc:Fallback xmlns="">
           <p:sp>
             <p:nvSpPr>
               <p:cNvPr id="36" name="TextBox 35">
@@ -19173,8 +19168,8 @@
           </a:p>
         </p:txBody>
       </p:sp>
-      <mc:AlternateContent xmlns:mc="http://schemas.openxmlformats.org/markup-compatibility/2006">
-        <mc:Choice xmlns:a14="http://schemas.microsoft.com/office/drawing/2010/main" Requires="a14">
+      <mc:AlternateContent xmlns:mc="http://schemas.openxmlformats.org/markup-compatibility/2006" xmlns:a14="http://schemas.microsoft.com/office/drawing/2010/main">
+        <mc:Choice Requires="a14">
           <p:sp>
             <p:nvSpPr>
               <p:cNvPr id="3" name="Content Placeholder 14">
@@ -19663,7 +19658,7 @@
             </p:txBody>
           </p:sp>
         </mc:Choice>
-        <mc:Fallback>
+        <mc:Fallback xmlns="">
           <p:sp>
             <p:nvSpPr>
               <p:cNvPr id="3" name="Content Placeholder 14">
@@ -19774,8 +19769,8 @@
           </a:p>
         </p:txBody>
       </p:sp>
-      <mc:AlternateContent xmlns:mc="http://schemas.openxmlformats.org/markup-compatibility/2006">
-        <mc:Choice xmlns:a14="http://schemas.microsoft.com/office/drawing/2010/main" Requires="a14">
+      <mc:AlternateContent xmlns:mc="http://schemas.openxmlformats.org/markup-compatibility/2006" xmlns:a14="http://schemas.microsoft.com/office/drawing/2010/main">
+        <mc:Choice Requires="a14">
           <p:sp>
             <p:nvSpPr>
               <p:cNvPr id="3" name="Content Placeholder 14">
@@ -20301,7 +20296,7 @@
             </p:txBody>
           </p:sp>
         </mc:Choice>
-        <mc:Fallback>
+        <mc:Fallback xmlns="">
           <p:sp>
             <p:nvSpPr>
               <p:cNvPr id="3" name="Content Placeholder 14">
@@ -20920,8 +20915,8 @@
           </a:fontRef>
         </p:style>
       </p:cxnSp>
-      <mc:AlternateContent xmlns:mc="http://schemas.openxmlformats.org/markup-compatibility/2006">
-        <mc:Choice xmlns:a14="http://schemas.microsoft.com/office/drawing/2010/main" Requires="a14">
+      <mc:AlternateContent xmlns:mc="http://schemas.openxmlformats.org/markup-compatibility/2006" xmlns:a14="http://schemas.microsoft.com/office/drawing/2010/main">
+        <mc:Choice Requires="a14">
           <p:sp>
             <p:nvSpPr>
               <p:cNvPr id="22" name="TextBox 21">
@@ -20971,7 +20966,7 @@
             </p:txBody>
           </p:sp>
         </mc:Choice>
-        <mc:Fallback>
+        <mc:Fallback xmlns="">
           <p:sp>
             <p:nvSpPr>
               <p:cNvPr id="22" name="TextBox 21">
@@ -21016,8 +21011,8 @@
           </p:sp>
         </mc:Fallback>
       </mc:AlternateContent>
-      <mc:AlternateContent xmlns:mc="http://schemas.openxmlformats.org/markup-compatibility/2006">
-        <mc:Choice xmlns:a14="http://schemas.microsoft.com/office/drawing/2010/main" Requires="a14">
+      <mc:AlternateContent xmlns:mc="http://schemas.openxmlformats.org/markup-compatibility/2006" xmlns:a14="http://schemas.microsoft.com/office/drawing/2010/main">
+        <mc:Choice Requires="a14">
           <p:sp>
             <p:nvSpPr>
               <p:cNvPr id="23" name="TextBox 22">
@@ -21067,7 +21062,7 @@
             </p:txBody>
           </p:sp>
         </mc:Choice>
-        <mc:Fallback>
+        <mc:Fallback xmlns="">
           <p:sp>
             <p:nvSpPr>
               <p:cNvPr id="23" name="TextBox 22">
@@ -22248,8 +22243,8 @@
           </a:p>
         </p:txBody>
       </p:sp>
-      <mc:AlternateContent xmlns:mc="http://schemas.openxmlformats.org/markup-compatibility/2006">
-        <mc:Choice xmlns:a14="http://schemas.microsoft.com/office/drawing/2010/main" Requires="a14">
+      <mc:AlternateContent xmlns:mc="http://schemas.openxmlformats.org/markup-compatibility/2006" xmlns:a14="http://schemas.microsoft.com/office/drawing/2010/main">
+        <mc:Choice Requires="a14">
           <p:sp>
             <p:nvSpPr>
               <p:cNvPr id="3" name="Content Placeholder 14">
@@ -22883,14 +22878,7 @@
                             <a:latin typeface="Cambria Math" panose="02040503050406030204" pitchFamily="18" charset="0"/>
                             <a:cs typeface="Arial" panose="020B0604020202020204" pitchFamily="34" charset="0"/>
                           </a:rPr>
-                          <m:t>,</m:t>
-                        </m:r>
-                        <m:r>
-                          <a:rPr lang="en-US" b="0" i="1" smtClean="0">
-                            <a:latin typeface="Cambria Math" panose="02040503050406030204" pitchFamily="18" charset="0"/>
-                            <a:cs typeface="Arial" panose="020B0604020202020204" pitchFamily="34" charset="0"/>
-                          </a:rPr>
-                          <m:t> </m:t>
+                          <m:t>, </m:t>
                         </m:r>
                         <m:d>
                           <m:dPr>
@@ -23078,7 +23066,7 @@
             </p:txBody>
           </p:sp>
         </mc:Choice>
-        <mc:Fallback>
+        <mc:Fallback xmlns="">
           <p:sp>
             <p:nvSpPr>
               <p:cNvPr id="3" name="Content Placeholder 14">
@@ -23189,8 +23177,8 @@
           </a:p>
         </p:txBody>
       </p:sp>
-      <mc:AlternateContent xmlns:mc="http://schemas.openxmlformats.org/markup-compatibility/2006">
-        <mc:Choice xmlns:a14="http://schemas.microsoft.com/office/drawing/2010/main" Requires="a14">
+      <mc:AlternateContent xmlns:mc="http://schemas.openxmlformats.org/markup-compatibility/2006" xmlns:a14="http://schemas.microsoft.com/office/drawing/2010/main">
+        <mc:Choice Requires="a14">
           <p:sp>
             <p:nvSpPr>
               <p:cNvPr id="3" name="Content Placeholder 14">
@@ -23468,7 +23456,7 @@
             </p:txBody>
           </p:sp>
         </mc:Choice>
-        <mc:Fallback>
+        <mc:Fallback xmlns="">
           <p:sp>
             <p:nvSpPr>
               <p:cNvPr id="3" name="Content Placeholder 14">

</xml_diff>